<commit_message>
minor tweak to data extraction roadmap
</commit_message>
<xml_diff>
--- a/docs/workflows/ROI_data_extraction_roadmap.pptx
+++ b/docs/workflows/ROI_data_extraction_roadmap.pptx
@@ -4556,7 +4556,7 @@
         </p:nvSpPr>
         <p:spPr>
           <a:xfrm>
-            <a:off x="10149840" y="137160"/>
+            <a:off x="10809059" y="105369"/>
             <a:ext cx="1280160" cy="228600"/>
           </a:xfrm>
           <a:prstGeom prst="rect">
@@ -4572,7 +4572,7 @@
           <a:p>
             <a:pPr algn="l"/>
             <a:r>
-              <a:rPr sz="1200" b="1">
+              <a:rPr sz="1200" b="1" dirty="0">
                 <a:solidFill>
                   <a:srgbClr val="262626"/>
                 </a:solidFill>
@@ -4591,7 +4591,7 @@
         </p:nvSpPr>
         <p:spPr>
           <a:xfrm>
-            <a:off x="10149840" y="411479"/>
+            <a:off x="10149840" y="356722"/>
             <a:ext cx="1828800" cy="219456"/>
           </a:xfrm>
           <a:prstGeom prst="rect">
@@ -4645,7 +4645,7 @@
         </p:nvSpPr>
         <p:spPr>
           <a:xfrm>
-            <a:off x="10149840" y="667512"/>
+            <a:off x="10149840" y="612755"/>
             <a:ext cx="1828800" cy="219456"/>
           </a:xfrm>
           <a:prstGeom prst="rect">
@@ -4699,7 +4699,7 @@
         </p:nvSpPr>
         <p:spPr>
           <a:xfrm>
-            <a:off x="10149840" y="923544"/>
+            <a:off x="10149840" y="868787"/>
             <a:ext cx="1828800" cy="219456"/>
           </a:xfrm>
           <a:prstGeom prst="rect">
@@ -4753,7 +4753,7 @@
         </p:nvSpPr>
         <p:spPr>
           <a:xfrm>
-            <a:off x="10149840" y="1179576"/>
+            <a:off x="10149840" y="1124819"/>
             <a:ext cx="1828800" cy="219456"/>
           </a:xfrm>
           <a:prstGeom prst="rect">
@@ -4807,8 +4807,8 @@
         </p:nvSpPr>
         <p:spPr>
           <a:xfrm>
-            <a:off x="320040" y="6263640"/>
-            <a:ext cx="11521440" cy="502920"/>
+            <a:off x="3991821" y="5669938"/>
+            <a:ext cx="7629565" cy="714042"/>
           </a:xfrm>
           <a:prstGeom prst="rect">
             <a:avLst/>
@@ -4821,18 +4821,63 @@
           </a:bodyPr>
           <a:lstStyle/>
           <a:p>
-            <a:pPr algn="l"/>
-            <a:r>
-              <a:rPr sz="950" b="0" dirty="0">
+            <a:pPr marL="171450" indent="-171450" algn="l">
+              <a:buFont typeface="Arial" panose="020B0604020202020204" pitchFamily="34" charset="0"/>
+              <a:buChar char="•"/>
+            </a:pPr>
+            <a:r>
+              <a:rPr sz="1100" b="0" dirty="0">
                 <a:solidFill>
                   <a:srgbClr val="262626"/>
                 </a:solidFill>
                 <a:latin typeface="Calibri"/>
               </a:rPr>
-              <a:t>Spaces &amp; resampling:  methods assume every image is registered to the same template space (e.g. MNI). Differing voxel grids are resampled automatically onto the data’s grid (nearest-neighbor for integer atlases); call </a:t>
-            </a:r>
-            <a:r>
-              <a:rPr sz="950" b="0" dirty="0" err="1">
+              <a:t>Spaces &amp; resampling:  methods assume every image is registered to the same template space (e.g. MNI). </a:t>
+            </a:r>
+            <a:endParaRPr lang="en-US" sz="1100" b="0" dirty="0">
+              <a:solidFill>
+                <a:srgbClr val="262626"/>
+              </a:solidFill>
+              <a:latin typeface="Calibri"/>
+            </a:endParaRPr>
+          </a:p>
+          <a:p>
+            <a:pPr marL="171450" indent="-171450" algn="l">
+              <a:buFont typeface="Arial" panose="020B0604020202020204" pitchFamily="34" charset="0"/>
+              <a:buChar char="•"/>
+            </a:pPr>
+            <a:r>
+              <a:rPr sz="1100" b="0" dirty="0">
+                <a:solidFill>
+                  <a:srgbClr val="262626"/>
+                </a:solidFill>
+                <a:latin typeface="Calibri"/>
+              </a:rPr>
+              <a:t>Differing voxel grids are resampled automatically onto the data’s grid (nearest-neighbor for integer atlases)</a:t>
+            </a:r>
+            <a:endParaRPr lang="en-US" sz="1100" b="0" dirty="0">
+              <a:solidFill>
+                <a:srgbClr val="262626"/>
+              </a:solidFill>
+              <a:latin typeface="Calibri"/>
+            </a:endParaRPr>
+          </a:p>
+          <a:p>
+            <a:pPr marL="171450" indent="-171450" algn="l">
+              <a:buFont typeface="Arial" panose="020B0604020202020204" pitchFamily="34" charset="0"/>
+              <a:buChar char="•"/>
+            </a:pPr>
+            <a:r>
+              <a:rPr sz="1100" b="0" dirty="0">
+                <a:solidFill>
+                  <a:srgbClr val="262626"/>
+                </a:solidFill>
+                <a:latin typeface="Calibri"/>
+              </a:rPr>
+              <a:t>call </a:t>
+            </a:r>
+            <a:r>
+              <a:rPr sz="1100" b="0" dirty="0" err="1">
                 <a:solidFill>
                   <a:srgbClr val="262626"/>
                 </a:solidFill>
@@ -4841,7 +4886,7 @@
               <a:t>resample_space</a:t>
             </a:r>
             <a:r>
-              <a:rPr sz="950" b="0" dirty="0">
+              <a:rPr sz="1100" b="0" dirty="0">
                 <a:solidFill>
                   <a:srgbClr val="262626"/>
                 </a:solidFill>
@@ -4850,7 +4895,7 @@
               <a:t>(a, b) to </a:t>
             </a:r>
             <a:r>
-              <a:rPr sz="950" b="0" dirty="0" err="1">
+              <a:rPr sz="1100" b="0" dirty="0" err="1">
                 <a:solidFill>
                   <a:srgbClr val="262626"/>
                 </a:solidFill>
@@ -4859,7 +4904,7 @@
               <a:t>reslice</a:t>
             </a:r>
             <a:r>
-              <a:rPr sz="950" b="0" dirty="0">
+              <a:rPr sz="1100" b="0" dirty="0">
                 <a:solidFill>
                   <a:srgbClr val="262626"/>
                 </a:solidFill>
@@ -4867,8 +4912,20 @@
               </a:rPr>
               <a:t> manually. </a:t>
             </a:r>
-            <a:r>
-              <a:rPr sz="950" b="0" dirty="0" err="1">
+            <a:endParaRPr lang="en-US" sz="1100" b="0" dirty="0">
+              <a:solidFill>
+                <a:srgbClr val="262626"/>
+              </a:solidFill>
+              <a:latin typeface="Calibri"/>
+            </a:endParaRPr>
+          </a:p>
+          <a:p>
+            <a:pPr marL="171450" indent="-171450" algn="l">
+              <a:buFont typeface="Arial" panose="020B0604020202020204" pitchFamily="34" charset="0"/>
+              <a:buChar char="•"/>
+            </a:pPr>
+            <a:r>
+              <a:rPr sz="1100" b="0" dirty="0" err="1">
                 <a:solidFill>
                   <a:srgbClr val="262626"/>
                 </a:solidFill>
@@ -4877,7 +4934,7 @@
               <a:t>region.extract_data</a:t>
             </a:r>
             <a:r>
-              <a:rPr sz="950" b="0" dirty="0">
+              <a:rPr sz="1100" b="0" dirty="0">
                 <a:solidFill>
                   <a:srgbClr val="262626"/>
                 </a:solidFill>
@@ -4962,6 +5019,108 @@
                 <a:latin typeface="Calibri"/>
               </a:rPr>
               <a:t>(for signatures, network maps, &amp; more)</a:t>
+            </a:r>
+            <a:endParaRPr sz="950" b="0" dirty="0">
+              <a:solidFill>
+                <a:srgbClr val="262626"/>
+              </a:solidFill>
+              <a:latin typeface="Calibri"/>
+            </a:endParaRPr>
+          </a:p>
+        </p:txBody>
+      </p:sp>
+      <p:sp>
+        <p:nvSpPr>
+          <p:cNvPr id="14" name="Rectangle 13">
+            <a:extLst>
+              <a:ext uri="{FF2B5EF4-FFF2-40B4-BE49-F238E27FC236}">
+                <a16:creationId xmlns:a16="http://schemas.microsoft.com/office/drawing/2014/main" id="{F503CF25-3205-806E-0C4D-8112DE540B7C}"/>
+              </a:ext>
+            </a:extLst>
+          </p:cNvPr>
+          <p:cNvSpPr/>
+          <p:nvPr/>
+        </p:nvSpPr>
+        <p:spPr>
+          <a:xfrm>
+            <a:off x="320040" y="6026959"/>
+            <a:ext cx="2331720" cy="420624"/>
+          </a:xfrm>
+          <a:prstGeom prst="rect">
+            <a:avLst/>
+          </a:prstGeom>
+          <a:solidFill>
+            <a:srgbClr val="DAE3F3"/>
+          </a:solidFill>
+          <a:ln w="6350">
+            <a:solidFill>
+              <a:srgbClr val="808080"/>
+            </a:solidFill>
+          </a:ln>
+        </p:spPr>
+        <p:style>
+          <a:lnRef idx="1">
+            <a:schemeClr val="accent1"/>
+          </a:lnRef>
+          <a:fillRef idx="3">
+            <a:schemeClr val="accent1"/>
+          </a:fillRef>
+          <a:effectRef idx="2">
+            <a:schemeClr val="accent1"/>
+          </a:effectRef>
+          <a:fontRef idx="minor">
+            <a:schemeClr val="lt1"/>
+          </a:fontRef>
+        </p:style>
+        <p:txBody>
+          <a:bodyPr wrap="square" lIns="36576" tIns="18288" rIns="36576" bIns="18288" rtlCol="0" anchor="ctr"/>
+          <a:lstStyle/>
+          <a:p>
+            <a:pPr algn="ctr"/>
+            <a:r>
+              <a:rPr lang="en-US" sz="950" b="0" dirty="0" err="1">
+                <a:solidFill>
+                  <a:srgbClr val="262626"/>
+                </a:solidFill>
+                <a:latin typeface="Calibri"/>
+              </a:rPr>
+              <a:t>load_atlas</a:t>
+            </a:r>
+            <a:r>
+              <a:rPr lang="en-US" sz="950" b="0" dirty="0">
+                <a:solidFill>
+                  <a:srgbClr val="262626"/>
+                </a:solidFill>
+                <a:latin typeface="Calibri"/>
+              </a:rPr>
+              <a:t> + </a:t>
+            </a:r>
+            <a:r>
+              <a:rPr lang="en-US" sz="950" b="0" dirty="0" err="1">
+                <a:solidFill>
+                  <a:srgbClr val="262626"/>
+                </a:solidFill>
+                <a:latin typeface="Calibri"/>
+              </a:rPr>
+              <a:t>select_atlas_subset</a:t>
+            </a:r>
+            <a:endParaRPr lang="en-US" sz="950" b="0" dirty="0">
+              <a:solidFill>
+                <a:srgbClr val="262626"/>
+              </a:solidFill>
+              <a:latin typeface="Calibri"/>
+            </a:endParaRPr>
+          </a:p>
+          <a:p>
+            <a:pPr algn="ctr"/>
+            <a:r>
+              <a:rPr lang="en-US" sz="950" dirty="0">
+                <a:solidFill>
+                  <a:srgbClr val="262626"/>
+                </a:solidFill>
+                <a:latin typeface="Calibri"/>
+              </a:rPr>
+              <a:t>(for named atlas regions/parcels)</a:t>
             </a:r>
             <a:endParaRPr sz="950" b="0" dirty="0">
               <a:solidFill>

</xml_diff>